<commit_message>
feat(brand): add BakerySense logo + apply to deck
- docs/brand/: logo-full (lockup) + logo-icon (icon only), checkerboard
  background keyed out to true transparency (bread slashes now show through
  correctly).
- Deck: amber logo icon on the title + close slides (correct contrast on
  the dark theme). Rebuilt pptx + pdf.

Co-Authored-By: Claude Opus 4.7 (1M context) <noreply@anthropic.com>
</commit_message>
<xml_diff>
--- a/docs/submission/bakerysense-ucws-deck.pptx
+++ b/docs/submission/bakerysense-ucws-deck.pptx
@@ -1587,36 +1587,40 @@
           <a:chExt cx="0" cy="0"/>
         </a:xfrm>
       </p:grpSpPr>
-      <p:sp>
-        <p:nvSpPr>
-          <p:cNvPr id="2" name="Shape 0"/>
-          <p:cNvSpPr/>
-          <p:nvPr/>
-        </p:nvSpPr>
-        <p:spPr>
-          <a:xfrm>
-            <a:off x="548640" y="585216"/>
-            <a:ext cx="128016" cy="128016"/>
-          </a:xfrm>
-          <a:prstGeom prst="ellipse">
-            <a:avLst/>
-          </a:prstGeom>
-          <a:solidFill>
-            <a:srgbClr val="E0A23C"/>
-          </a:solidFill>
-          <a:ln/>
-        </p:spPr>
-      </p:sp>
-      <p:sp>
-        <p:nvSpPr>
-          <p:cNvPr id="3" name="Text 1"/>
-          <p:cNvSpPr/>
-          <p:nvPr/>
-        </p:nvSpPr>
-        <p:spPr>
-          <a:xfrm>
-            <a:off x="804672" y="493776"/>
-            <a:ext cx="7315200" cy="365760"/>
+      <p:pic>
+        <p:nvPicPr>
+          <p:cNvPr id="2" name="Image 0" descr="/Users/sohweimeng/Documents/projects/bakerysense/docs/submission/deck/logo-icon.png">    </p:cNvPr>
+          <p:cNvPicPr>
+            <a:picLocks noChangeAspect="1"/>
+          </p:cNvPicPr>
+          <p:nvPr/>
+        </p:nvPicPr>
+        <p:blipFill>
+          <a:blip r:embed="rId1"/>
+          <a:stretch>
+            <a:fillRect/>
+          </a:stretch>
+        </p:blipFill>
+        <p:spPr>
+          <a:xfrm>
+            <a:off x="548640" y="457200"/>
+            <a:ext cx="1188720" cy="1106424"/>
+          </a:xfrm>
+          <a:prstGeom prst="rect">
+            <a:avLst/>
+          </a:prstGeom>
+        </p:spPr>
+      </p:pic>
+      <p:sp>
+        <p:nvSpPr>
+          <p:cNvPr id="3" name="Text 0"/>
+          <p:cNvSpPr/>
+          <p:nvPr/>
+        </p:nvSpPr>
+        <p:spPr>
+          <a:xfrm>
+            <a:off x="1965960" y="841248"/>
+            <a:ext cx="8229600" cy="365760"/>
           </a:xfrm>
           <a:prstGeom prst="rect">
             <a:avLst/>
@@ -1648,13 +1652,13 @@
       </p:sp>
       <p:sp>
         <p:nvSpPr>
-          <p:cNvPr id="4" name="Text 2"/>
-          <p:cNvSpPr/>
-          <p:nvPr/>
-        </p:nvSpPr>
-        <p:spPr>
-          <a:xfrm>
-            <a:off x="548640" y="2011680"/>
+          <p:cNvPr id="4" name="Text 1"/>
+          <p:cNvSpPr/>
+          <p:nvPr/>
+        </p:nvSpPr>
+        <p:spPr>
+          <a:xfrm>
+            <a:off x="548640" y="2103120"/>
             <a:ext cx="10058400" cy="1280160"/>
           </a:xfrm>
           <a:prstGeom prst="rect">
@@ -1687,7 +1691,7 @@
       </p:sp>
       <p:sp>
         <p:nvSpPr>
-          <p:cNvPr id="5" name="Text 3"/>
+          <p:cNvPr id="5" name="Text 2"/>
           <p:cNvSpPr/>
           <p:nvPr/>
         </p:nvSpPr>
@@ -1740,7 +1744,7 @@
       </p:sp>
       <p:sp>
         <p:nvSpPr>
-          <p:cNvPr id="6" name="Text 4"/>
+          <p:cNvPr id="6" name="Text 3"/>
           <p:cNvSpPr/>
           <p:nvPr/>
         </p:nvSpPr>
@@ -1782,7 +1786,7 @@
       </p:sp>
       <p:sp>
         <p:nvSpPr>
-          <p:cNvPr id="7" name="Text 5"/>
+          <p:cNvPr id="7" name="Text 4"/>
           <p:cNvSpPr/>
           <p:nvPr/>
         </p:nvSpPr>
@@ -5074,9 +5078,33 @@
           <a:chExt cx="0" cy="0"/>
         </a:xfrm>
       </p:grpSpPr>
-      <p:sp>
-        <p:nvSpPr>
-          <p:cNvPr id="2" name="Text 0"/>
+      <p:pic>
+        <p:nvPicPr>
+          <p:cNvPr id="2" name="Image 0" descr="/Users/sohweimeng/Documents/projects/bakerysense/docs/submission/deck/logo-icon.png">    </p:cNvPr>
+          <p:cNvPicPr>
+            <a:picLocks noChangeAspect="1"/>
+          </p:cNvPicPr>
+          <p:nvPr/>
+        </p:nvPicPr>
+        <p:blipFill>
+          <a:blip r:embed="rId1"/>
+          <a:stretch>
+            <a:fillRect/>
+          </a:stretch>
+        </p:blipFill>
+        <p:spPr>
+          <a:xfrm>
+            <a:off x="10424160" y="502920"/>
+            <a:ext cx="1234440" cy="1152144"/>
+          </a:xfrm>
+          <a:prstGeom prst="rect">
+            <a:avLst/>
+          </a:prstGeom>
+        </p:spPr>
+      </p:pic>
+      <p:sp>
+        <p:nvSpPr>
+          <p:cNvPr id="3" name="Text 0"/>
           <p:cNvSpPr/>
           <p:nvPr/>
         </p:nvSpPr>
@@ -5115,7 +5143,7 @@
       </p:sp>
       <p:sp>
         <p:nvSpPr>
-          <p:cNvPr id="3" name="Text 1"/>
+          <p:cNvPr id="4" name="Text 1"/>
           <p:cNvSpPr/>
           <p:nvPr/>
         </p:nvSpPr>
@@ -5154,7 +5182,7 @@
       </p:sp>
       <p:sp>
         <p:nvSpPr>
-          <p:cNvPr id="4" name="Text 2"/>
+          <p:cNvPr id="5" name="Text 2"/>
           <p:cNvSpPr/>
           <p:nvPr/>
         </p:nvSpPr>
@@ -5326,7 +5354,7 @@
       </p:sp>
       <p:sp>
         <p:nvSpPr>
-          <p:cNvPr id="5" name="Text 3"/>
+          <p:cNvPr id="6" name="Text 3"/>
           <p:cNvSpPr/>
           <p:nvPr/>
         </p:nvSpPr>

</xml_diff>